<commit_message>
Fold transport into audio, drop stats row on one-pager
Audio now shows $600 including setup and pick-up; bottom breakdown is
Equipment $1,450 and Crew $1,200. Total unchanged at $2,650.

Co-Authored-By: Claude Opus 5.5 <noreply@anthropic.com>
Claude-Session: https://claude.ai/code/session_017uhWxcvQLLnDQKisxUaLUC
</commit_message>
<xml_diff>
--- a/one-pager/quote/helix-2026-10-22-editable.pptx
+++ b/one-pager/quote/helix-2026-10-22-editable.pptx
@@ -3262,20 +3262,57 @@
       </p:sp>
       <p:sp>
         <p:nvSpPr>
-          <p:cNvPr id="6" name="Rule"/>
+          <p:cNvPr id="6" name="TextBox 5"/>
+          <p:cNvSpPr txBox="1"/>
+          <p:nvPr/>
+        </p:nvSpPr>
+        <p:spPr>
+          <a:xfrm>
+            <a:off x="640080" y="2331720"/>
+            <a:ext cx="3657600" cy="274320"/>
+          </a:xfrm>
+          <a:prstGeom prst="rect">
+            <a:avLst/>
+          </a:prstGeom>
+          <a:noFill/>
+        </p:spPr>
+        <p:txBody>
+          <a:bodyPr wrap="square" lIns="0" rIns="0" tIns="0" bIns="0" anchor="t"/>
+          <a:lstStyle/>
+          <a:p>
+            <a:pPr algn="l">
+              <a:lnSpc>
+                <a:spcPct val="100000"/>
+              </a:lnSpc>
+            </a:pPr>
+            <a:r>
+              <a:rPr sz="1400" b="1">
+                <a:solidFill>
+                  <a:srgbClr val="171717"/>
+                </a:solidFill>
+                <a:latin typeface="Inter"/>
+              </a:rPr>
+              <a:t>What’s included</a:t>
+            </a:r>
+          </a:p>
+        </p:txBody>
+      </p:sp>
+      <p:sp>
+        <p:nvSpPr>
+          <p:cNvPr id="7" name="Rule"/>
           <p:cNvSpPr/>
           <p:nvPr/>
         </p:nvSpPr>
         <p:spPr>
           <a:xfrm>
-            <a:off x="640080" y="2487168"/>
+            <a:off x="640080" y="2651760"/>
             <a:ext cx="6492240" cy="9525"/>
           </a:xfrm>
           <a:prstGeom prst="rect">
             <a:avLst/>
           </a:prstGeom>
           <a:solidFill>
-            <a:srgbClr val="171717"/>
+            <a:srgbClr val="E7E5E0"/>
           </a:solidFill>
           <a:ln>
             <a:noFill/>
@@ -3306,14 +3343,14 @@
       </p:sp>
       <p:sp>
         <p:nvSpPr>
-          <p:cNvPr id="7" name="Stat 1"/>
+          <p:cNvPr id="8" name="Crew name"/>
           <p:cNvSpPr txBox="1"/>
           <p:nvPr/>
         </p:nvSpPr>
         <p:spPr>
           <a:xfrm>
-            <a:off x="640080" y="2615184"/>
-            <a:ext cx="2072640" cy="320040"/>
+            <a:off x="640080" y="2770632"/>
+            <a:ext cx="4754880" cy="201168"/>
           </a:xfrm>
           <a:prstGeom prst="rect">
             <a:avLst/>
@@ -3330,27 +3367,27 @@
               </a:lnSpc>
             </a:pPr>
             <a:r>
-              <a:rPr sz="1900" b="1">
+              <a:rPr sz="1100" b="1">
                 <a:solidFill>
                   <a:srgbClr val="171717"/>
                 </a:solidFill>
                 <a:latin typeface="Inter"/>
               </a:rPr>
-              <a:t>$10,236</a:t>
-            </a:r>
-          </a:p>
-        </p:txBody>
-      </p:sp>
-      <p:sp>
-        <p:nvSpPr>
-          <p:cNvPr id="8" name="Stat 1 label"/>
+              <a:t>Crew</a:t>
+            </a:r>
+          </a:p>
+        </p:txBody>
+      </p:sp>
+      <p:sp>
+        <p:nvSpPr>
+          <p:cNvPr id="9" name="Crew description"/>
           <p:cNvSpPr txBox="1"/>
           <p:nvPr/>
         </p:nvSpPr>
         <p:spPr>
           <a:xfrm>
-            <a:off x="640080" y="2944368"/>
-            <a:ext cx="2072640" cy="182880"/>
+            <a:off x="640080" y="2962656"/>
+            <a:ext cx="4754880" cy="182880"/>
           </a:xfrm>
           <a:prstGeom prst="rect">
             <a:avLst/>
@@ -3367,27 +3404,27 @@
               </a:lnSpc>
             </a:pPr>
             <a:r>
-              <a:rPr sz="800" b="0">
+              <a:rPr sz="850" b="0">
                 <a:solidFill>
                   <a:srgbClr val="6B6B6B"/>
                 </a:solidFill>
                 <a:latin typeface="Inter"/>
               </a:rPr>
-              <a:t>of equipment on site</a:t>
-            </a:r>
-          </a:p>
-        </p:txBody>
-      </p:sp>
-      <p:sp>
-        <p:nvSpPr>
-          <p:cNvPr id="9" name="Stat 2"/>
+              <a:t>Senior audio technician (A1), video technician (V1)</a:t>
+            </a:r>
+          </a:p>
+        </p:txBody>
+      </p:sp>
+      <p:sp>
+        <p:nvSpPr>
+          <p:cNvPr id="10" name="Crew price"/>
           <p:cNvSpPr txBox="1"/>
           <p:nvPr/>
         </p:nvSpPr>
         <p:spPr>
           <a:xfrm>
-            <a:off x="2804160" y="2615184"/>
-            <a:ext cx="2072640" cy="320040"/>
+            <a:off x="5669279" y="2651760"/>
+            <a:ext cx="1463040" cy="525780"/>
           </a:xfrm>
           <a:prstGeom prst="rect">
             <a:avLst/>
@@ -3395,183 +3432,35 @@
           <a:noFill/>
         </p:spPr>
         <p:txBody>
-          <a:bodyPr wrap="square" lIns="0" rIns="0" tIns="0" bIns="0" anchor="t"/>
-          <a:lstStyle/>
-          <a:p>
-            <a:pPr algn="l">
+          <a:bodyPr wrap="square" lIns="0" rIns="0" tIns="0" bIns="0" anchor="ctr"/>
+          <a:lstStyle/>
+          <a:p>
+            <a:pPr algn="r">
               <a:lnSpc>
                 <a:spcPct val="100000"/>
               </a:lnSpc>
             </a:pPr>
             <a:r>
-              <a:rPr sz="1900" b="1">
+              <a:rPr sz="1400" b="1">
                 <a:solidFill>
                   <a:srgbClr val="171717"/>
                 </a:solidFill>
                 <a:latin typeface="Inter"/>
               </a:rPr>
-              <a:t>2</a:t>
-            </a:r>
-          </a:p>
-        </p:txBody>
-      </p:sp>
-      <p:sp>
-        <p:nvSpPr>
-          <p:cNvPr id="10" name="Stat 2 label"/>
-          <p:cNvSpPr txBox="1"/>
-          <p:nvPr/>
-        </p:nvSpPr>
-        <p:spPr>
-          <a:xfrm>
-            <a:off x="2804160" y="2944368"/>
-            <a:ext cx="2072640" cy="182880"/>
-          </a:xfrm>
-          <a:prstGeom prst="rect">
-            <a:avLst/>
-          </a:prstGeom>
-          <a:noFill/>
-        </p:spPr>
-        <p:txBody>
-          <a:bodyPr wrap="square" lIns="0" rIns="0" tIns="0" bIns="0" anchor="t"/>
-          <a:lstStyle/>
-          <a:p>
-            <a:pPr algn="l">
-              <a:lnSpc>
-                <a:spcPct val="100000"/>
-              </a:lnSpc>
-            </a:pPr>
-            <a:r>
-              <a:rPr sz="800" b="0">
-                <a:solidFill>
-                  <a:srgbClr val="6B6B6B"/>
-                </a:solidFill>
-                <a:latin typeface="Inter"/>
-              </a:rPr>
-              <a:t>technicians, all day</a:t>
-            </a:r>
-          </a:p>
-        </p:txBody>
-      </p:sp>
-      <p:sp>
-        <p:nvSpPr>
-          <p:cNvPr id="11" name="Stat 3"/>
-          <p:cNvSpPr txBox="1"/>
-          <p:nvPr/>
-        </p:nvSpPr>
-        <p:spPr>
-          <a:xfrm>
-            <a:off x="4968240" y="2615184"/>
-            <a:ext cx="2072640" cy="320040"/>
-          </a:xfrm>
-          <a:prstGeom prst="rect">
-            <a:avLst/>
-          </a:prstGeom>
-          <a:noFill/>
-        </p:spPr>
-        <p:txBody>
-          <a:bodyPr wrap="square" lIns="0" rIns="0" tIns="0" bIns="0" anchor="t"/>
-          <a:lstStyle/>
-          <a:p>
-            <a:pPr algn="l">
-              <a:lnSpc>
-                <a:spcPct val="100000"/>
-              </a:lnSpc>
-            </a:pPr>
-            <a:r>
-              <a:rPr sz="1900" b="1">
-                <a:solidFill>
-                  <a:srgbClr val="171717"/>
-                </a:solidFill>
-                <a:latin typeface="Inter"/>
-              </a:rPr>
-              <a:t>9 AM – 5 PM</a:t>
-            </a:r>
-          </a:p>
-        </p:txBody>
-      </p:sp>
-      <p:sp>
-        <p:nvSpPr>
-          <p:cNvPr id="12" name="Stat 3 label"/>
-          <p:cNvSpPr txBox="1"/>
-          <p:nvPr/>
-        </p:nvSpPr>
-        <p:spPr>
-          <a:xfrm>
-            <a:off x="4968240" y="2944368"/>
-            <a:ext cx="2072640" cy="182880"/>
-          </a:xfrm>
-          <a:prstGeom prst="rect">
-            <a:avLst/>
-          </a:prstGeom>
-          <a:noFill/>
-        </p:spPr>
-        <p:txBody>
-          <a:bodyPr wrap="square" lIns="0" rIns="0" tIns="0" bIns="0" anchor="t"/>
-          <a:lstStyle/>
-          <a:p>
-            <a:pPr algn="l">
-              <a:lnSpc>
-                <a:spcPct val="100000"/>
-              </a:lnSpc>
-            </a:pPr>
-            <a:r>
-              <a:rPr sz="800" b="0">
-                <a:solidFill>
-                  <a:srgbClr val="6B6B6B"/>
-                </a:solidFill>
-                <a:latin typeface="Inter"/>
-              </a:rPr>
-              <a:t>Thu, Oct 22 · New Brunswick</a:t>
-            </a:r>
-          </a:p>
-        </p:txBody>
-      </p:sp>
-      <p:sp>
-        <p:nvSpPr>
-          <p:cNvPr id="13" name="TextBox 12"/>
-          <p:cNvSpPr txBox="1"/>
-          <p:nvPr/>
-        </p:nvSpPr>
-        <p:spPr>
-          <a:xfrm>
-            <a:off x="640080" y="3474720"/>
-            <a:ext cx="3657600" cy="274320"/>
-          </a:xfrm>
-          <a:prstGeom prst="rect">
-            <a:avLst/>
-          </a:prstGeom>
-          <a:noFill/>
-        </p:spPr>
-        <p:txBody>
-          <a:bodyPr wrap="square" lIns="0" rIns="0" tIns="0" bIns="0" anchor="t"/>
-          <a:lstStyle/>
-          <a:p>
-            <a:pPr algn="l">
-              <a:lnSpc>
-                <a:spcPct val="100000"/>
-              </a:lnSpc>
-            </a:pPr>
-            <a:r>
-              <a:rPr sz="1400" b="1">
-                <a:solidFill>
-                  <a:srgbClr val="171717"/>
-                </a:solidFill>
-                <a:latin typeface="Inter"/>
-              </a:rPr>
-              <a:t>What’s included</a:t>
-            </a:r>
-          </a:p>
-        </p:txBody>
-      </p:sp>
-      <p:sp>
-        <p:nvSpPr>
-          <p:cNvPr id="14" name="Rule"/>
+              <a:t>$1,200</a:t>
+            </a:r>
+          </a:p>
+        </p:txBody>
+      </p:sp>
+      <p:sp>
+        <p:nvSpPr>
+          <p:cNvPr id="11" name="Rule"/>
           <p:cNvSpPr/>
           <p:nvPr/>
         </p:nvSpPr>
         <p:spPr>
           <a:xfrm>
-            <a:off x="640080" y="3794760"/>
+            <a:off x="640080" y="3177539"/>
             <a:ext cx="6492240" cy="9525"/>
           </a:xfrm>
           <a:prstGeom prst="rect">
@@ -3609,13 +3498,13 @@
       </p:sp>
       <p:sp>
         <p:nvSpPr>
-          <p:cNvPr id="15" name="Crew name"/>
+          <p:cNvPr id="12" name="Video name"/>
           <p:cNvSpPr txBox="1"/>
           <p:nvPr/>
         </p:nvSpPr>
         <p:spPr>
           <a:xfrm>
-            <a:off x="640080" y="3913632"/>
+            <a:off x="640080" y="3296411"/>
             <a:ext cx="4754880" cy="201168"/>
           </a:xfrm>
           <a:prstGeom prst="rect">
@@ -3639,20 +3528,20 @@
                 </a:solidFill>
                 <a:latin typeface="Inter"/>
               </a:rPr>
-              <a:t>Crew</a:t>
-            </a:r>
-          </a:p>
-        </p:txBody>
-      </p:sp>
-      <p:sp>
-        <p:nvSpPr>
-          <p:cNvPr id="16" name="Crew description"/>
+              <a:t>Video</a:t>
+            </a:r>
+          </a:p>
+        </p:txBody>
+      </p:sp>
+      <p:sp>
+        <p:nvSpPr>
+          <p:cNvPr id="13" name="Video description"/>
           <p:cNvSpPr txBox="1"/>
           <p:nvPr/>
         </p:nvSpPr>
         <p:spPr>
           <a:xfrm>
-            <a:off x="640080" y="4105656"/>
+            <a:off x="640080" y="3488435"/>
             <a:ext cx="4754880" cy="182880"/>
           </a:xfrm>
           <a:prstGeom prst="rect">
@@ -3676,20 +3565,20 @@
                 </a:solidFill>
                 <a:latin typeface="Inter"/>
               </a:rPr>
-              <a:t>Senior audio technician (A1), video technician (V1)</a:t>
-            </a:r>
-          </a:p>
-        </p:txBody>
-      </p:sp>
-      <p:sp>
-        <p:nvSpPr>
-          <p:cNvPr id="17" name="Crew price"/>
+              <a:t>BirdDog X5 Ultra PTZ camera, Roland V-02HD MK II mixer, MacBook Air M2</a:t>
+            </a:r>
+          </a:p>
+        </p:txBody>
+      </p:sp>
+      <p:sp>
+        <p:nvSpPr>
+          <p:cNvPr id="14" name="Video price"/>
           <p:cNvSpPr txBox="1"/>
           <p:nvPr/>
         </p:nvSpPr>
         <p:spPr>
           <a:xfrm>
-            <a:off x="5669279" y="3794760"/>
+            <a:off x="5669279" y="3177539"/>
             <a:ext cx="1463040" cy="525780"/>
           </a:xfrm>
           <a:prstGeom prst="rect">
@@ -3713,20 +3602,20 @@
                 </a:solidFill>
                 <a:latin typeface="Inter"/>
               </a:rPr>
-              <a:t>$1,200</a:t>
-            </a:r>
-          </a:p>
-        </p:txBody>
-      </p:sp>
-      <p:sp>
-        <p:nvSpPr>
-          <p:cNvPr id="18" name="Rule"/>
+              <a:t>$850</a:t>
+            </a:r>
+          </a:p>
+        </p:txBody>
+      </p:sp>
+      <p:sp>
+        <p:nvSpPr>
+          <p:cNvPr id="15" name="Rule"/>
           <p:cNvSpPr/>
           <p:nvPr/>
         </p:nvSpPr>
         <p:spPr>
           <a:xfrm>
-            <a:off x="640080" y="4320540"/>
+            <a:off x="640080" y="3703320"/>
             <a:ext cx="6492240" cy="9525"/>
           </a:xfrm>
           <a:prstGeom prst="rect">
@@ -3764,13 +3653,13 @@
       </p:sp>
       <p:sp>
         <p:nvSpPr>
-          <p:cNvPr id="19" name="Video name"/>
+          <p:cNvPr id="16" name="Audio name"/>
           <p:cNvSpPr txBox="1"/>
           <p:nvPr/>
         </p:nvSpPr>
         <p:spPr>
           <a:xfrm>
-            <a:off x="640080" y="4439412"/>
+            <a:off x="640080" y="3822191"/>
             <a:ext cx="4754880" cy="201168"/>
           </a:xfrm>
           <a:prstGeom prst="rect">
@@ -3794,20 +3683,20 @@
                 </a:solidFill>
                 <a:latin typeface="Inter"/>
               </a:rPr>
-              <a:t>Video</a:t>
-            </a:r>
-          </a:p>
-        </p:txBody>
-      </p:sp>
-      <p:sp>
-        <p:nvSpPr>
-          <p:cNvPr id="20" name="Video description"/>
+              <a:t>Audio</a:t>
+            </a:r>
+          </a:p>
+        </p:txBody>
+      </p:sp>
+      <p:sp>
+        <p:nvSpPr>
+          <p:cNvPr id="17" name="Audio description"/>
           <p:cNvSpPr txBox="1"/>
           <p:nvPr/>
         </p:nvSpPr>
         <p:spPr>
           <a:xfrm>
-            <a:off x="640080" y="4631436"/>
+            <a:off x="640080" y="4014215"/>
             <a:ext cx="4754880" cy="182880"/>
           </a:xfrm>
           <a:prstGeom prst="rect">
@@ -3831,20 +3720,20 @@
                 </a:solidFill>
                 <a:latin typeface="Inter"/>
               </a:rPr>
-              <a:t>BirdDog X5 Ultra PTZ camera, Roland V-02HD MK II mixer, MacBook Air M2</a:t>
-            </a:r>
-          </a:p>
-        </p:txBody>
-      </p:sp>
-      <p:sp>
-        <p:nvSpPr>
-          <p:cNvPr id="21" name="Video price"/>
+              <a:t>Focusrite Scarlett 2i2, Radial direct boxes, iPad, setup and pick-up</a:t>
+            </a:r>
+          </a:p>
+        </p:txBody>
+      </p:sp>
+      <p:sp>
+        <p:nvSpPr>
+          <p:cNvPr id="18" name="Audio price"/>
           <p:cNvSpPr txBox="1"/>
           <p:nvPr/>
         </p:nvSpPr>
         <p:spPr>
           <a:xfrm>
-            <a:off x="5669279" y="4320540"/>
+            <a:off x="5669279" y="3703320"/>
             <a:ext cx="1463040" cy="525780"/>
           </a:xfrm>
           <a:prstGeom prst="rect">
@@ -3868,21 +3757,95 @@
                 </a:solidFill>
                 <a:latin typeface="Inter"/>
               </a:rPr>
-              <a:t>$850</a:t>
-            </a:r>
-          </a:p>
-        </p:txBody>
-      </p:sp>
-      <p:sp>
-        <p:nvSpPr>
-          <p:cNvPr id="22" name="Rule"/>
+              <a:t>$600</a:t>
+            </a:r>
+          </a:p>
+        </p:txBody>
+      </p:sp>
+      <p:sp>
+        <p:nvSpPr>
+          <p:cNvPr id="19" name="TextBox 18"/>
+          <p:cNvSpPr txBox="1"/>
+          <p:nvPr/>
+        </p:nvSpPr>
+        <p:spPr>
+          <a:xfrm>
+            <a:off x="640080" y="4709160"/>
+            <a:ext cx="3657600" cy="274320"/>
+          </a:xfrm>
+          <a:prstGeom prst="rect">
+            <a:avLst/>
+          </a:prstGeom>
+          <a:noFill/>
+        </p:spPr>
+        <p:txBody>
+          <a:bodyPr wrap="square" lIns="0" rIns="0" tIns="0" bIns="0" anchor="t"/>
+          <a:lstStyle/>
+          <a:p>
+            <a:pPr algn="l">
+              <a:lnSpc>
+                <a:spcPct val="100000"/>
+              </a:lnSpc>
+            </a:pPr>
+            <a:r>
+              <a:rPr sz="1400" b="1">
+                <a:solidFill>
+                  <a:srgbClr val="171717"/>
+                </a:solidFill>
+                <a:latin typeface="Inter"/>
+              </a:rPr>
+              <a:t>Also in this quote</a:t>
+            </a:r>
+          </a:p>
+        </p:txBody>
+      </p:sp>
+      <p:sp>
+        <p:nvSpPr>
+          <p:cNvPr id="20" name="Also 1"/>
+          <p:cNvSpPr txBox="1"/>
+          <p:nvPr/>
+        </p:nvSpPr>
+        <p:spPr>
+          <a:xfrm>
+            <a:off x="640080" y="5074920"/>
+            <a:ext cx="3131820" cy="201168"/>
+          </a:xfrm>
+          <a:prstGeom prst="rect">
+            <a:avLst/>
+          </a:prstGeom>
+          <a:noFill/>
+        </p:spPr>
+        <p:txBody>
+          <a:bodyPr wrap="square" lIns="0" rIns="0" tIns="0" bIns="0" anchor="t"/>
+          <a:lstStyle/>
+          <a:p>
+            <a:pPr algn="l">
+              <a:lnSpc>
+                <a:spcPct val="100000"/>
+              </a:lnSpc>
+            </a:pPr>
+            <a:r>
+              <a:rPr sz="900" b="0">
+                <a:solidFill>
+                  <a:srgbClr val="171717"/>
+                </a:solidFill>
+                <a:latin typeface="Inter"/>
+              </a:rPr>
+              <a:t>✓   Joystick camera controller</a:t>
+            </a:r>
+          </a:p>
+        </p:txBody>
+      </p:sp>
+      <p:sp>
+        <p:nvSpPr>
+          <p:cNvPr id="21" name="Rule"/>
           <p:cNvSpPr/>
           <p:nvPr/>
         </p:nvSpPr>
         <p:spPr>
           <a:xfrm>
-            <a:off x="640080" y="4846320"/>
-            <a:ext cx="6492240" cy="9525"/>
+            <a:off x="640080" y="5321808"/>
+            <a:ext cx="3131820" cy="9525"/>
           </a:xfrm>
           <a:prstGeom prst="rect">
             <a:avLst/>
@@ -3919,14 +3882,14 @@
       </p:sp>
       <p:sp>
         <p:nvSpPr>
-          <p:cNvPr id="23" name="Audio name"/>
+          <p:cNvPr id="22" name="Also 2"/>
           <p:cNvSpPr txBox="1"/>
           <p:nvPr/>
         </p:nvSpPr>
         <p:spPr>
           <a:xfrm>
-            <a:off x="640080" y="4965192"/>
-            <a:ext cx="4754880" cy="201168"/>
+            <a:off x="640080" y="5340096"/>
+            <a:ext cx="3131820" cy="201168"/>
           </a:xfrm>
           <a:prstGeom prst="rect">
             <a:avLst/>
@@ -3943,101 +3906,27 @@
               </a:lnSpc>
             </a:pPr>
             <a:r>
-              <a:rPr sz="1100" b="1">
+              <a:rPr sz="900" b="0">
                 <a:solidFill>
                   <a:srgbClr val="171717"/>
                 </a:solidFill>
                 <a:latin typeface="Inter"/>
               </a:rPr>
-              <a:t>Audio</a:t>
-            </a:r>
-          </a:p>
-        </p:txBody>
-      </p:sp>
-      <p:sp>
-        <p:nvSpPr>
-          <p:cNvPr id="24" name="Audio description"/>
-          <p:cNvSpPr txBox="1"/>
-          <p:nvPr/>
-        </p:nvSpPr>
-        <p:spPr>
-          <a:xfrm>
-            <a:off x="640080" y="5157216"/>
-            <a:ext cx="4754880" cy="182880"/>
-          </a:xfrm>
-          <a:prstGeom prst="rect">
-            <a:avLst/>
-          </a:prstGeom>
-          <a:noFill/>
-        </p:spPr>
-        <p:txBody>
-          <a:bodyPr wrap="square" lIns="0" rIns="0" tIns="0" bIns="0" anchor="t"/>
-          <a:lstStyle/>
-          <a:p>
-            <a:pPr algn="l">
-              <a:lnSpc>
-                <a:spcPct val="100000"/>
-              </a:lnSpc>
-            </a:pPr>
-            <a:r>
-              <a:rPr sz="850" b="0">
-                <a:solidFill>
-                  <a:srgbClr val="6B6B6B"/>
-                </a:solidFill>
-                <a:latin typeface="Inter"/>
-              </a:rPr>
-              <a:t>Focusrite Scarlett 2i2, Radial direct boxes, iPad</a:t>
-            </a:r>
-          </a:p>
-        </p:txBody>
-      </p:sp>
-      <p:sp>
-        <p:nvSpPr>
-          <p:cNvPr id="25" name="Audio price"/>
-          <p:cNvSpPr txBox="1"/>
-          <p:nvPr/>
-        </p:nvSpPr>
-        <p:spPr>
-          <a:xfrm>
-            <a:off x="5669279" y="4846320"/>
-            <a:ext cx="1463040" cy="525780"/>
-          </a:xfrm>
-          <a:prstGeom prst="rect">
-            <a:avLst/>
-          </a:prstGeom>
-          <a:noFill/>
-        </p:spPr>
-        <p:txBody>
-          <a:bodyPr wrap="square" lIns="0" rIns="0" tIns="0" bIns="0" anchor="ctr"/>
-          <a:lstStyle/>
-          <a:p>
-            <a:pPr algn="r">
-              <a:lnSpc>
-                <a:spcPct val="100000"/>
-              </a:lnSpc>
-            </a:pPr>
-            <a:r>
-              <a:rPr sz="1400" b="1">
-                <a:solidFill>
-                  <a:srgbClr val="171717"/>
-                </a:solidFill>
-                <a:latin typeface="Inter"/>
-              </a:rPr>
-              <a:t>$100</a:t>
-            </a:r>
-          </a:p>
-        </p:txBody>
-      </p:sp>
-      <p:sp>
-        <p:nvSpPr>
-          <p:cNvPr id="26" name="Rule"/>
+              <a:t>✓   SDI and HDMI cable package</a:t>
+            </a:r>
+          </a:p>
+        </p:txBody>
+      </p:sp>
+      <p:sp>
+        <p:nvSpPr>
+          <p:cNvPr id="23" name="Rule"/>
           <p:cNvSpPr/>
           <p:nvPr/>
         </p:nvSpPr>
         <p:spPr>
           <a:xfrm>
-            <a:off x="640080" y="5372100"/>
-            <a:ext cx="6492240" cy="9525"/>
+            <a:off x="640080" y="5586983"/>
+            <a:ext cx="3131820" cy="9525"/>
           </a:xfrm>
           <a:prstGeom prst="rect">
             <a:avLst/>
@@ -4074,14 +3963,14 @@
       </p:sp>
       <p:sp>
         <p:nvSpPr>
-          <p:cNvPr id="27" name="Transport name"/>
+          <p:cNvPr id="24" name="Also 3"/>
           <p:cNvSpPr txBox="1"/>
           <p:nvPr/>
         </p:nvSpPr>
         <p:spPr>
           <a:xfrm>
-            <a:off x="640080" y="5490972"/>
-            <a:ext cx="4754880" cy="201168"/>
+            <a:off x="640080" y="5605272"/>
+            <a:ext cx="3131820" cy="201168"/>
           </a:xfrm>
           <a:prstGeom prst="rect">
             <a:avLst/>
@@ -4098,174 +3987,26 @@
               </a:lnSpc>
             </a:pPr>
             <a:r>
-              <a:rPr sz="1100" b="1">
+              <a:rPr sz="900" b="0">
                 <a:solidFill>
                   <a:srgbClr val="171717"/>
                 </a:solidFill>
                 <a:latin typeface="Inter"/>
               </a:rPr>
-              <a:t>Transport</a:t>
-            </a:r>
-          </a:p>
-        </p:txBody>
-      </p:sp>
-      <p:sp>
-        <p:nvSpPr>
-          <p:cNvPr id="28" name="Transport description"/>
-          <p:cNvSpPr txBox="1"/>
-          <p:nvPr/>
-        </p:nvSpPr>
-        <p:spPr>
-          <a:xfrm>
-            <a:off x="640080" y="5682996"/>
-            <a:ext cx="4754880" cy="182880"/>
-          </a:xfrm>
-          <a:prstGeom prst="rect">
-            <a:avLst/>
-          </a:prstGeom>
-          <a:noFill/>
-        </p:spPr>
-        <p:txBody>
-          <a:bodyPr wrap="square" lIns="0" rIns="0" tIns="0" bIns="0" anchor="t"/>
-          <a:lstStyle/>
-          <a:p>
-            <a:pPr algn="l">
-              <a:lnSpc>
-                <a:spcPct val="100000"/>
-              </a:lnSpc>
-            </a:pPr>
-            <a:r>
-              <a:rPr sz="850" b="0">
-                <a:solidFill>
-                  <a:srgbClr val="6B6B6B"/>
-                </a:solidFill>
-                <a:latin typeface="Inter"/>
-              </a:rPr>
-              <a:t>Delivery, setup, and pick-up</a:t>
-            </a:r>
-          </a:p>
-        </p:txBody>
-      </p:sp>
-      <p:sp>
-        <p:nvSpPr>
-          <p:cNvPr id="29" name="Transport price"/>
-          <p:cNvSpPr txBox="1"/>
-          <p:nvPr/>
-        </p:nvSpPr>
-        <p:spPr>
-          <a:xfrm>
-            <a:off x="5669279" y="5372100"/>
-            <a:ext cx="1463040" cy="525780"/>
-          </a:xfrm>
-          <a:prstGeom prst="rect">
-            <a:avLst/>
-          </a:prstGeom>
-          <a:noFill/>
-        </p:spPr>
-        <p:txBody>
-          <a:bodyPr wrap="square" lIns="0" rIns="0" tIns="0" bIns="0" anchor="ctr"/>
-          <a:lstStyle/>
-          <a:p>
-            <a:pPr algn="r">
-              <a:lnSpc>
-                <a:spcPct val="100000"/>
-              </a:lnSpc>
-            </a:pPr>
-            <a:r>
-              <a:rPr sz="1400" b="1">
-                <a:solidFill>
-                  <a:srgbClr val="171717"/>
-                </a:solidFill>
-                <a:latin typeface="Inter"/>
-              </a:rPr>
-              <a:t>$500</a:t>
-            </a:r>
-          </a:p>
-        </p:txBody>
-      </p:sp>
-      <p:sp>
-        <p:nvSpPr>
-          <p:cNvPr id="30" name="TextBox 29"/>
-          <p:cNvSpPr txBox="1"/>
-          <p:nvPr/>
-        </p:nvSpPr>
-        <p:spPr>
-          <a:xfrm>
-            <a:off x="640080" y="6263640"/>
-            <a:ext cx="3657600" cy="274320"/>
-          </a:xfrm>
-          <a:prstGeom prst="rect">
-            <a:avLst/>
-          </a:prstGeom>
-          <a:noFill/>
-        </p:spPr>
-        <p:txBody>
-          <a:bodyPr wrap="square" lIns="0" rIns="0" tIns="0" bIns="0" anchor="t"/>
-          <a:lstStyle/>
-          <a:p>
-            <a:pPr algn="l">
-              <a:lnSpc>
-                <a:spcPct val="100000"/>
-              </a:lnSpc>
-            </a:pPr>
-            <a:r>
-              <a:rPr sz="1400" b="1">
-                <a:solidFill>
-                  <a:srgbClr val="171717"/>
-                </a:solidFill>
-                <a:latin typeface="Inter"/>
-              </a:rPr>
-              <a:t>Also in this quote</a:t>
-            </a:r>
-          </a:p>
-        </p:txBody>
-      </p:sp>
-      <p:sp>
-        <p:nvSpPr>
-          <p:cNvPr id="31" name="Also 1"/>
-          <p:cNvSpPr txBox="1"/>
-          <p:nvPr/>
-        </p:nvSpPr>
-        <p:spPr>
-          <a:xfrm>
-            <a:off x="640080" y="6629400"/>
-            <a:ext cx="3131820" cy="201168"/>
-          </a:xfrm>
-          <a:prstGeom prst="rect">
-            <a:avLst/>
-          </a:prstGeom>
-          <a:noFill/>
-        </p:spPr>
-        <p:txBody>
-          <a:bodyPr wrap="square" lIns="0" rIns="0" tIns="0" bIns="0" anchor="t"/>
-          <a:lstStyle/>
-          <a:p>
-            <a:pPr algn="l">
-              <a:lnSpc>
-                <a:spcPct val="100000"/>
-              </a:lnSpc>
-            </a:pPr>
-            <a:r>
-              <a:rPr sz="900" b="0">
-                <a:solidFill>
-                  <a:srgbClr val="171717"/>
-                </a:solidFill>
-                <a:latin typeface="Inter"/>
-              </a:rPr>
-              <a:t>✓   Joystick camera controller</a:t>
-            </a:r>
-          </a:p>
-        </p:txBody>
-      </p:sp>
-      <p:sp>
-        <p:nvSpPr>
-          <p:cNvPr id="32" name="Rule"/>
+              <a:t>✓   Remote pan, tilt, and zoom</a:t>
+            </a:r>
+          </a:p>
+        </p:txBody>
+      </p:sp>
+      <p:sp>
+        <p:nvSpPr>
+          <p:cNvPr id="25" name="Rule"/>
           <p:cNvSpPr/>
           <p:nvPr/>
         </p:nvSpPr>
         <p:spPr>
           <a:xfrm>
-            <a:off x="640080" y="6876288"/>
+            <a:off x="640080" y="5852160"/>
             <a:ext cx="3131820" cy="9525"/>
           </a:xfrm>
           <a:prstGeom prst="rect">
@@ -4303,13 +4044,13 @@
       </p:sp>
       <p:sp>
         <p:nvSpPr>
-          <p:cNvPr id="33" name="Also 2"/>
+          <p:cNvPr id="26" name="Also 4"/>
           <p:cNvSpPr txBox="1"/>
           <p:nvPr/>
         </p:nvSpPr>
         <p:spPr>
           <a:xfrm>
-            <a:off x="640080" y="6894576"/>
+            <a:off x="4000500" y="5074920"/>
             <a:ext cx="3131820" cy="201168"/>
           </a:xfrm>
           <a:prstGeom prst="rect">
@@ -4333,20 +4074,20 @@
                 </a:solidFill>
                 <a:latin typeface="Inter"/>
               </a:rPr>
-              <a:t>✓   SDI and HDMI cable package</a:t>
-            </a:r>
-          </a:p>
-        </p:txBody>
-      </p:sp>
-      <p:sp>
-        <p:nvSpPr>
-          <p:cNvPr id="34" name="Rule"/>
+              <a:t>✓   4K camera monitor for the technician</a:t>
+            </a:r>
+          </a:p>
+        </p:txBody>
+      </p:sp>
+      <p:sp>
+        <p:nvSpPr>
+          <p:cNvPr id="27" name="Rule"/>
           <p:cNvSpPr/>
           <p:nvPr/>
         </p:nvSpPr>
         <p:spPr>
           <a:xfrm>
-            <a:off x="640080" y="7141464"/>
+            <a:off x="4000500" y="5321808"/>
             <a:ext cx="3131820" cy="9525"/>
           </a:xfrm>
           <a:prstGeom prst="rect">
@@ -4384,13 +4125,13 @@
       </p:sp>
       <p:sp>
         <p:nvSpPr>
-          <p:cNvPr id="35" name="Also 3"/>
+          <p:cNvPr id="28" name="Also 5"/>
           <p:cNvSpPr txBox="1"/>
           <p:nvPr/>
         </p:nvSpPr>
         <p:spPr>
           <a:xfrm>
-            <a:off x="640080" y="7159752"/>
+            <a:off x="4000500" y="5340096"/>
             <a:ext cx="3131820" cy="201168"/>
           </a:xfrm>
           <a:prstGeom prst="rect">
@@ -4414,20 +4155,20 @@
                 </a:solidFill>
                 <a:latin typeface="Inter"/>
               </a:rPr>
-              <a:t>✓   Remote pan, tilt, and zoom</a:t>
-            </a:r>
-          </a:p>
-        </p:txBody>
-      </p:sp>
-      <p:sp>
-        <p:nvSpPr>
-          <p:cNvPr id="36" name="Rule"/>
+              <a:t>✓   PoE+ network switch</a:t>
+            </a:r>
+          </a:p>
+        </p:txBody>
+      </p:sp>
+      <p:sp>
+        <p:nvSpPr>
+          <p:cNvPr id="29" name="Rule"/>
           <p:cNvSpPr/>
           <p:nvPr/>
         </p:nvSpPr>
         <p:spPr>
           <a:xfrm>
-            <a:off x="640080" y="7406640"/>
+            <a:off x="4000500" y="5586983"/>
             <a:ext cx="3131820" cy="9525"/>
           </a:xfrm>
           <a:prstGeom prst="rect">
@@ -4465,13 +4206,13 @@
       </p:sp>
       <p:sp>
         <p:nvSpPr>
-          <p:cNvPr id="37" name="Also 4"/>
+          <p:cNvPr id="30" name="Also 6"/>
           <p:cNvSpPr txBox="1"/>
           <p:nvPr/>
         </p:nvSpPr>
         <p:spPr>
           <a:xfrm>
-            <a:off x="4000500" y="6629400"/>
+            <a:off x="4000500" y="5605272"/>
             <a:ext cx="3131820" cy="201168"/>
           </a:xfrm>
           <a:prstGeom prst="rect">
@@ -4495,20 +4236,20 @@
                 </a:solidFill>
                 <a:latin typeface="Inter"/>
               </a:rPr>
-              <a:t>✓   4K camera monitor for the technician</a:t>
-            </a:r>
-          </a:p>
-        </p:txBody>
-      </p:sp>
-      <p:sp>
-        <p:nvSpPr>
-          <p:cNvPr id="38" name="Rule"/>
+              <a:t>✓   Camera tripods</a:t>
+            </a:r>
+          </a:p>
+        </p:txBody>
+      </p:sp>
+      <p:sp>
+        <p:nvSpPr>
+          <p:cNvPr id="31" name="Rule"/>
           <p:cNvSpPr/>
           <p:nvPr/>
         </p:nvSpPr>
         <p:spPr>
           <a:xfrm>
-            <a:off x="4000500" y="6876288"/>
+            <a:off x="4000500" y="5852160"/>
             <a:ext cx="3131820" cy="9525"/>
           </a:xfrm>
           <a:prstGeom prst="rect">
@@ -4546,57 +4287,20 @@
       </p:sp>
       <p:sp>
         <p:nvSpPr>
-          <p:cNvPr id="39" name="Also 5"/>
-          <p:cNvSpPr txBox="1"/>
-          <p:nvPr/>
-        </p:nvSpPr>
-        <p:spPr>
-          <a:xfrm>
-            <a:off x="4000500" y="6894576"/>
-            <a:ext cx="3131820" cy="201168"/>
-          </a:xfrm>
-          <a:prstGeom prst="rect">
-            <a:avLst/>
-          </a:prstGeom>
-          <a:noFill/>
-        </p:spPr>
-        <p:txBody>
-          <a:bodyPr wrap="square" lIns="0" rIns="0" tIns="0" bIns="0" anchor="t"/>
-          <a:lstStyle/>
-          <a:p>
-            <a:pPr algn="l">
-              <a:lnSpc>
-                <a:spcPct val="100000"/>
-              </a:lnSpc>
-            </a:pPr>
-            <a:r>
-              <a:rPr sz="900" b="0">
-                <a:solidFill>
-                  <a:srgbClr val="171717"/>
-                </a:solidFill>
-                <a:latin typeface="Inter"/>
-              </a:rPr>
-              <a:t>✓   PoE+ network switch</a:t>
-            </a:r>
-          </a:p>
-        </p:txBody>
-      </p:sp>
-      <p:sp>
-        <p:nvSpPr>
-          <p:cNvPr id="40" name="Rule"/>
+          <p:cNvPr id="32" name="Rule"/>
           <p:cNvSpPr/>
           <p:nvPr/>
         </p:nvSpPr>
         <p:spPr>
           <a:xfrm>
-            <a:off x="4000500" y="7141464"/>
-            <a:ext cx="3131820" cy="9525"/>
+            <a:off x="640080" y="6400800"/>
+            <a:ext cx="6492240" cy="15875"/>
           </a:xfrm>
           <a:prstGeom prst="rect">
             <a:avLst/>
           </a:prstGeom>
           <a:solidFill>
-            <a:srgbClr val="E7E5E0"/>
+            <a:srgbClr val="171717"/>
           </a:solidFill>
           <a:ln>
             <a:noFill/>
@@ -4627,14 +4331,14 @@
       </p:sp>
       <p:sp>
         <p:nvSpPr>
-          <p:cNvPr id="41" name="Also 6"/>
+          <p:cNvPr id="33" name="TextBox 32"/>
           <p:cNvSpPr txBox="1"/>
           <p:nvPr/>
         </p:nvSpPr>
         <p:spPr>
           <a:xfrm>
-            <a:off x="4000500" y="7159752"/>
-            <a:ext cx="3131820" cy="201168"/>
+            <a:off x="640080" y="6501384"/>
+            <a:ext cx="1828800" cy="146304"/>
           </a:xfrm>
           <a:prstGeom prst="rect">
             <a:avLst/>
@@ -4651,115 +4355,27 @@
               </a:lnSpc>
             </a:pPr>
             <a:r>
-              <a:rPr sz="900" b="0">
-                <a:solidFill>
-                  <a:srgbClr val="171717"/>
+              <a:rPr sz="750" b="1">
+                <a:solidFill>
+                  <a:srgbClr val="E8382F"/>
                 </a:solidFill>
                 <a:latin typeface="Inter"/>
               </a:rPr>
-              <a:t>✓   Camera tripods</a:t>
-            </a:r>
-          </a:p>
-        </p:txBody>
-      </p:sp>
-      <p:sp>
-        <p:nvSpPr>
-          <p:cNvPr id="42" name="Rule"/>
-          <p:cNvSpPr/>
-          <p:nvPr/>
-        </p:nvSpPr>
-        <p:spPr>
-          <a:xfrm>
-            <a:off x="4000500" y="7406640"/>
-            <a:ext cx="3131820" cy="9525"/>
-          </a:xfrm>
-          <a:prstGeom prst="rect">
-            <a:avLst/>
-          </a:prstGeom>
-          <a:solidFill>
-            <a:srgbClr val="E7E5E0"/>
-          </a:solidFill>
-          <a:ln>
-            <a:noFill/>
-          </a:ln>
-          <a:effectLst/>
-        </p:spPr>
-        <p:style>
-          <a:lnRef idx="1">
-            <a:schemeClr val="accent1"/>
-          </a:lnRef>
-          <a:fillRef idx="3">
-            <a:schemeClr val="accent1"/>
-          </a:fillRef>
-          <a:effectRef idx="0">
-            <a:schemeClr val="accent1"/>
-          </a:effectRef>
-          <a:fontRef idx="minor">
-            <a:schemeClr val="lt1"/>
-          </a:fontRef>
-        </p:style>
-        <p:txBody>
-          <a:bodyPr rtlCol="0" anchor="ctr"/>
-          <a:lstStyle/>
-          <a:p>
-            <a:pPr algn="ctr"/>
-          </a:p>
-        </p:txBody>
-      </p:sp>
-      <p:sp>
-        <p:nvSpPr>
-          <p:cNvPr id="43" name="Rule"/>
-          <p:cNvSpPr/>
-          <p:nvPr/>
-        </p:nvSpPr>
-        <p:spPr>
-          <a:xfrm>
-            <a:off x="640080" y="7818120"/>
-            <a:ext cx="6492240" cy="15875"/>
-          </a:xfrm>
-          <a:prstGeom prst="rect">
-            <a:avLst/>
-          </a:prstGeom>
-          <a:solidFill>
-            <a:srgbClr val="171717"/>
-          </a:solidFill>
-          <a:ln>
-            <a:noFill/>
-          </a:ln>
-          <a:effectLst/>
-        </p:spPr>
-        <p:style>
-          <a:lnRef idx="1">
-            <a:schemeClr val="accent1"/>
-          </a:lnRef>
-          <a:fillRef idx="3">
-            <a:schemeClr val="accent1"/>
-          </a:fillRef>
-          <a:effectRef idx="0">
-            <a:schemeClr val="accent1"/>
-          </a:effectRef>
-          <a:fontRef idx="minor">
-            <a:schemeClr val="lt1"/>
-          </a:fontRef>
-        </p:style>
-        <p:txBody>
-          <a:bodyPr rtlCol="0" anchor="ctr"/>
-          <a:lstStyle/>
-          <a:p>
-            <a:pPr algn="ctr"/>
-          </a:p>
-        </p:txBody>
-      </p:sp>
-      <p:sp>
-        <p:nvSpPr>
-          <p:cNvPr id="44" name="TextBox 43"/>
+              <a:t>TOTAL</a:t>
+            </a:r>
+          </a:p>
+        </p:txBody>
+      </p:sp>
+      <p:sp>
+        <p:nvSpPr>
+          <p:cNvPr id="34" name="Total"/>
           <p:cNvSpPr txBox="1"/>
           <p:nvPr/>
         </p:nvSpPr>
         <p:spPr>
           <a:xfrm>
-            <a:off x="640080" y="7918704"/>
-            <a:ext cx="1828800" cy="146304"/>
+            <a:off x="640080" y="6629400"/>
+            <a:ext cx="3657600" cy="502920"/>
           </a:xfrm>
           <a:prstGeom prst="rect">
             <a:avLst/>
@@ -4776,27 +4392,27 @@
               </a:lnSpc>
             </a:pPr>
             <a:r>
-              <a:rPr sz="750" b="1">
-                <a:solidFill>
-                  <a:srgbClr val="E8382F"/>
+              <a:rPr sz="3200" b="1">
+                <a:solidFill>
+                  <a:srgbClr val="171717"/>
                 </a:solidFill>
                 <a:latin typeface="Inter"/>
               </a:rPr>
-              <a:t>TOTAL</a:t>
-            </a:r>
-          </a:p>
-        </p:txBody>
-      </p:sp>
-      <p:sp>
-        <p:nvSpPr>
-          <p:cNvPr id="45" name="Total"/>
+              <a:t>$2,650</a:t>
+            </a:r>
+          </a:p>
+        </p:txBody>
+      </p:sp>
+      <p:sp>
+        <p:nvSpPr>
+          <p:cNvPr id="35" name="TextBox 34"/>
           <p:cNvSpPr txBox="1"/>
           <p:nvPr/>
         </p:nvSpPr>
         <p:spPr>
           <a:xfrm>
-            <a:off x="640080" y="8046720"/>
-            <a:ext cx="3657600" cy="502920"/>
+            <a:off x="4754879" y="6556248"/>
+            <a:ext cx="1645920" cy="155448"/>
           </a:xfrm>
           <a:prstGeom prst="rect">
             <a:avLst/>
@@ -4813,26 +4429,63 @@
               </a:lnSpc>
             </a:pPr>
             <a:r>
-              <a:rPr sz="3200" b="1">
-                <a:solidFill>
-                  <a:srgbClr val="171717"/>
+              <a:rPr sz="850" b="0">
+                <a:solidFill>
+                  <a:srgbClr val="6B6B6B"/>
                 </a:solidFill>
                 <a:latin typeface="Inter"/>
               </a:rPr>
-              <a:t>$2,650</a:t>
-            </a:r>
-          </a:p>
-        </p:txBody>
-      </p:sp>
-      <p:sp>
-        <p:nvSpPr>
-          <p:cNvPr id="46" name="TextBox 45"/>
+              <a:t>Equipment</a:t>
+            </a:r>
+          </a:p>
+        </p:txBody>
+      </p:sp>
+      <p:sp>
+        <p:nvSpPr>
+          <p:cNvPr id="36" name="Equipment amount"/>
           <p:cNvSpPr txBox="1"/>
           <p:nvPr/>
         </p:nvSpPr>
         <p:spPr>
           <a:xfrm>
-            <a:off x="4754879" y="7973568"/>
+            <a:off x="6400800" y="6556248"/>
+            <a:ext cx="731520" cy="155448"/>
+          </a:xfrm>
+          <a:prstGeom prst="rect">
+            <a:avLst/>
+          </a:prstGeom>
+          <a:noFill/>
+        </p:spPr>
+        <p:txBody>
+          <a:bodyPr wrap="square" lIns="0" rIns="0" tIns="0" bIns="0" anchor="t"/>
+          <a:lstStyle/>
+          <a:p>
+            <a:pPr algn="r">
+              <a:lnSpc>
+                <a:spcPct val="100000"/>
+              </a:lnSpc>
+            </a:pPr>
+            <a:r>
+              <a:rPr sz="850" b="0">
+                <a:solidFill>
+                  <a:srgbClr val="6B6B6B"/>
+                </a:solidFill>
+                <a:latin typeface="Inter"/>
+              </a:rPr>
+              <a:t>$1,450</a:t>
+            </a:r>
+          </a:p>
+        </p:txBody>
+      </p:sp>
+      <p:sp>
+        <p:nvSpPr>
+          <p:cNvPr id="37" name="TextBox 36"/>
+          <p:cNvSpPr txBox="1"/>
+          <p:nvPr/>
+        </p:nvSpPr>
+        <p:spPr>
+          <a:xfrm>
+            <a:off x="4754879" y="6729984"/>
             <a:ext cx="1645920" cy="155448"/>
           </a:xfrm>
           <a:prstGeom prst="rect">
@@ -4856,20 +4509,20 @@
                 </a:solidFill>
                 <a:latin typeface="Inter"/>
               </a:rPr>
-              <a:t>Equipment rental</a:t>
-            </a:r>
-          </a:p>
-        </p:txBody>
-      </p:sp>
-      <p:sp>
-        <p:nvSpPr>
-          <p:cNvPr id="47" name="Equipment rental amount"/>
+              <a:t>Crew</a:t>
+            </a:r>
+          </a:p>
+        </p:txBody>
+      </p:sp>
+      <p:sp>
+        <p:nvSpPr>
+          <p:cNvPr id="38" name="Crew amount"/>
           <p:cNvSpPr txBox="1"/>
           <p:nvPr/>
         </p:nvSpPr>
         <p:spPr>
           <a:xfrm>
-            <a:off x="6400800" y="7973568"/>
+            <a:off x="6400800" y="6729984"/>
             <a:ext cx="731520" cy="155448"/>
           </a:xfrm>
           <a:prstGeom prst="rect">
@@ -4893,20 +4546,20 @@
                 </a:solidFill>
                 <a:latin typeface="Inter"/>
               </a:rPr>
-              <a:t>$950</a:t>
-            </a:r>
-          </a:p>
-        </p:txBody>
-      </p:sp>
-      <p:sp>
-        <p:nvSpPr>
-          <p:cNvPr id="48" name="TextBox 47"/>
+              <a:t>$1,200</a:t>
+            </a:r>
+          </a:p>
+        </p:txBody>
+      </p:sp>
+      <p:sp>
+        <p:nvSpPr>
+          <p:cNvPr id="39" name="TextBox 38"/>
           <p:cNvSpPr txBox="1"/>
           <p:nvPr/>
         </p:nvSpPr>
         <p:spPr>
           <a:xfrm>
-            <a:off x="4754879" y="8147304"/>
+            <a:off x="4754879" y="6903720"/>
             <a:ext cx="1645920" cy="155448"/>
           </a:xfrm>
           <a:prstGeom prst="rect">
@@ -4930,20 +4583,20 @@
                 </a:solidFill>
                 <a:latin typeface="Inter"/>
               </a:rPr>
-              <a:t>Crew and transport</a:t>
-            </a:r>
-          </a:p>
-        </p:txBody>
-      </p:sp>
-      <p:sp>
-        <p:nvSpPr>
-          <p:cNvPr id="49" name="Crew and transport amount"/>
+              <a:t>Tax</a:t>
+            </a:r>
+          </a:p>
+        </p:txBody>
+      </p:sp>
+      <p:sp>
+        <p:nvSpPr>
+          <p:cNvPr id="40" name="Tax amount"/>
           <p:cNvSpPr txBox="1"/>
           <p:nvPr/>
         </p:nvSpPr>
         <p:spPr>
           <a:xfrm>
-            <a:off x="6400800" y="8147304"/>
+            <a:off x="6400800" y="6903720"/>
             <a:ext cx="731520" cy="155448"/>
           </a:xfrm>
           <a:prstGeom prst="rect">
@@ -4967,21 +4620,21 @@
                 </a:solidFill>
                 <a:latin typeface="Inter"/>
               </a:rPr>
-              <a:t>$1,700</a:t>
-            </a:r>
-          </a:p>
-        </p:txBody>
-      </p:sp>
-      <p:sp>
-        <p:nvSpPr>
-          <p:cNvPr id="50" name="TextBox 49"/>
+              <a:t>$0</a:t>
+            </a:r>
+          </a:p>
+        </p:txBody>
+      </p:sp>
+      <p:sp>
+        <p:nvSpPr>
+          <p:cNvPr id="41" name="Contact"/>
           <p:cNvSpPr txBox="1"/>
           <p:nvPr/>
         </p:nvSpPr>
         <p:spPr>
           <a:xfrm>
-            <a:off x="4754879" y="8321040"/>
-            <a:ext cx="1645920" cy="155448"/>
+            <a:off x="640080" y="7406640"/>
+            <a:ext cx="6492240" cy="182880"/>
           </a:xfrm>
           <a:prstGeom prst="rect">
             <a:avLst/>
@@ -4998,80 +4651,6 @@
               </a:lnSpc>
             </a:pPr>
             <a:r>
-              <a:rPr sz="850" b="0">
-                <a:solidFill>
-                  <a:srgbClr val="6B6B6B"/>
-                </a:solidFill>
-                <a:latin typeface="Inter"/>
-              </a:rPr>
-              <a:t>Tax</a:t>
-            </a:r>
-          </a:p>
-        </p:txBody>
-      </p:sp>
-      <p:sp>
-        <p:nvSpPr>
-          <p:cNvPr id="51" name="Tax amount"/>
-          <p:cNvSpPr txBox="1"/>
-          <p:nvPr/>
-        </p:nvSpPr>
-        <p:spPr>
-          <a:xfrm>
-            <a:off x="6400800" y="8321040"/>
-            <a:ext cx="731520" cy="155448"/>
-          </a:xfrm>
-          <a:prstGeom prst="rect">
-            <a:avLst/>
-          </a:prstGeom>
-          <a:noFill/>
-        </p:spPr>
-        <p:txBody>
-          <a:bodyPr wrap="square" lIns="0" rIns="0" tIns="0" bIns="0" anchor="t"/>
-          <a:lstStyle/>
-          <a:p>
-            <a:pPr algn="r">
-              <a:lnSpc>
-                <a:spcPct val="100000"/>
-              </a:lnSpc>
-            </a:pPr>
-            <a:r>
-              <a:rPr sz="850" b="0">
-                <a:solidFill>
-                  <a:srgbClr val="6B6B6B"/>
-                </a:solidFill>
-                <a:latin typeface="Inter"/>
-              </a:rPr>
-              <a:t>$0</a:t>
-            </a:r>
-          </a:p>
-        </p:txBody>
-      </p:sp>
-      <p:sp>
-        <p:nvSpPr>
-          <p:cNvPr id="52" name="Contact"/>
-          <p:cNvSpPr txBox="1"/>
-          <p:nvPr/>
-        </p:nvSpPr>
-        <p:spPr>
-          <a:xfrm>
-            <a:off x="640080" y="8823960"/>
-            <a:ext cx="6492240" cy="182880"/>
-          </a:xfrm>
-          <a:prstGeom prst="rect">
-            <a:avLst/>
-          </a:prstGeom>
-          <a:noFill/>
-        </p:spPr>
-        <p:txBody>
-          <a:bodyPr wrap="square" lIns="0" rIns="0" tIns="0" bIns="0" anchor="t"/>
-          <a:lstStyle/>
-          <a:p>
-            <a:pPr algn="l">
-              <a:lnSpc>
-                <a:spcPct val="100000"/>
-              </a:lnSpc>
-            </a:pPr>
-            <a:r>
               <a:rPr sz="900" b="0">
                 <a:solidFill>
                   <a:srgbClr val="6B6B6B"/>
@@ -5085,7 +4664,7 @@
       </p:sp>
       <p:sp>
         <p:nvSpPr>
-          <p:cNvPr id="53" name="Validity"/>
+          <p:cNvPr id="42" name="Validity"/>
           <p:cNvSpPr txBox="1"/>
           <p:nvPr/>
         </p:nvSpPr>

</xml_diff>

<commit_message>
Name the one-pager the Zoom Call Package
Kicker, headline, and section heading now carry the package name; audio
line drops the setup and pick-up mention.

Co-Authored-By: Claude Opus 5.5 <noreply@anthropic.com>
Claude-Session: https://claude.ai/code/session_017uhWxcvQLLnDQKisxUaLUC
</commit_message>
<xml_diff>
--- a/one-pager/quote/helix-2026-10-22-editable.pptx
+++ b/one-pager/quote/helix-2026-10-22-editable.pptx
@@ -3202,7 +3202,7 @@
                 </a:solidFill>
                 <a:latin typeface="Inter"/>
               </a:rPr>
-              <a:t>HELIX · OCTOBER 22, 2026</a:t>
+              <a:t>ZOOM CALL PACKAGE · HELIX · OCTOBER 22, 2026</a:t>
             </a:r>
           </a:p>
         </p:txBody>
@@ -3239,7 +3239,7 @@
                 </a:solidFill>
                 <a:latin typeface="Inter"/>
               </a:rPr>
-              <a:t>Your event</a:t>
+              <a:t>Your Zoom call</a:t>
             </a:r>
           </a:p>
           <a:p>
@@ -3292,7 +3292,7 @@
                 </a:solidFill>
                 <a:latin typeface="Inter"/>
               </a:rPr>
-              <a:t>What’s included</a:t>
+              <a:t>What’s in the package</a:t>
             </a:r>
           </a:p>
         </p:txBody>
@@ -3720,7 +3720,7 @@
                 </a:solidFill>
                 <a:latin typeface="Inter"/>
               </a:rPr>
-              <a:t>Focusrite Scarlett 2i2, Radial direct boxes, iPad, setup and pick-up</a:t>
+              <a:t>Focusrite Scarlett 2i2, Radial direct boxes, iPad</a:t>
             </a:r>
           </a:p>
         </p:txBody>

</xml_diff>

<commit_message>
Headline the one-pager "Your Zoom Call Package"
Co-Authored-By: Claude Opus 5.5 <noreply@anthropic.com>
Claude-Session: https://claude.ai/code/session_017uhWxcvQLLnDQKisxUaLUC
</commit_message>
<xml_diff>
--- a/one-pager/quote/helix-2026-10-22-editable.pptx
+++ b/one-pager/quote/helix-2026-10-22-editable.pptx
@@ -3202,7 +3202,7 @@
                 </a:solidFill>
                 <a:latin typeface="Inter"/>
               </a:rPr>
-              <a:t>ZOOM CALL PACKAGE · HELIX · OCTOBER 22, 2026</a:t>
+              <a:t>HELIX · OCTOBER 22, 2026</a:t>
             </a:r>
           </a:p>
         </p:txBody>
@@ -3239,7 +3239,7 @@
                 </a:solidFill>
                 <a:latin typeface="Inter"/>
               </a:rPr>
-              <a:t>Your Zoom call</a:t>
+              <a:t>Your Zoom</a:t>
             </a:r>
           </a:p>
           <a:p>
@@ -3255,7 +3255,7 @@
                 </a:solidFill>
                 <a:latin typeface="Inter"/>
               </a:rPr>
-              <a:t>just works.</a:t>
+              <a:t>Call Package</a:t>
             </a:r>
           </a:p>
         </p:txBody>

</xml_diff>